<commit_message>
Grille en 4 formules : comptes bureau, formule Business, présentation à jour
Co-Authored-By: Claude Opus 5.5 (1M context) <noreply@anthropic.com>
Claude-Session: https://claude.ai/code/session_01N3XgRSA54QNAqzXFjQaqJw
</commit_message>
<xml_diff>
--- a/presentation/GeoPulse-presentation.pptx
+++ b/presentation/GeoPulse-presentation.pptx
@@ -126,7 +126,7 @@
   <p:extLst>
     <p:ext uri="{521415D9-36F7-43E2-AB2F-B90AF26B5E84}">
       <p14:sectionLst xmlns:p14="http://schemas.microsoft.com/office/powerpoint/2010/main">
-        <p14:section name="Ouverture" id="{a898e8b3-4786-ac37-cfb7-9b5f95755234}">
+        <p14:section name="Ouverture" id="{d177a207-d157-9780-87e9-9d0fc309bf7f}">
           <p14:sldIdLst>
             <p14:sldId id="256"/>
             <p14:sldId id="257"/>
@@ -134,7 +134,7 @@
             <p14:sldId id="259"/>
           </p14:sldIdLst>
         </p14:section>
-        <p14:section name="Fonctionnalités" id="{7eb86de1-d360-3e15-98a9-7d9f7d6fc273}">
+        <p14:section name="Fonctionnalités" id="{b9f14f0c-49f5-57c8-7946-b6cf592dfdbb}">
           <p14:sldIdLst>
             <p14:sldId id="260"/>
             <p14:sldId id="261"/>
@@ -149,7 +149,7 @@
             <p14:sldId id="270"/>
           </p14:sldIdLst>
         </p14:section>
-        <p14:section name="Mise en route" id="{9a6d1647-2337-aaf4-8a17-de51e155fc9f}">
+        <p14:section name="Mise en route" id="{4f2ad179-8e7b-cc44-7423-ab14e3a9cbb9}">
           <p14:sldIdLst>
             <p14:sldId id="271"/>
             <p14:sldId id="272"/>
@@ -157,7 +157,7 @@
             <p14:sldId id="274"/>
           </p14:sldIdLst>
         </p14:section>
-        <p14:section name="Conclusion" id="{a3474583-e0d6-42bf-24d4-6027da5bfa40}">
+        <p14:section name="Conclusion" id="{406692b4-57a7-c9ea-4b27-a8aef5703d94}">
           <p14:sldIdLst>
             <p14:sldId id="275"/>
           </p14:sldIdLst>
@@ -1446,7 +1446,7 @@
           <a:p>
             <a:r>
               <a:rPr lang="en-US" dirty="0"/>
-              <a:t>Prix à confirmer avant diffusion : ce sont les prix proposés dans la console GeoPulse, modifiables à tout moment.</a:t>
+              <a:t>Grille 2026 : quatre formules de 390 à 1 900 TND HT par mois. En annuel, 10 mois payés pour 12. Au-delà du plafond, chaque commercial coûte 15 TND HT par mois.</a:t>
             </a:r>
             <a:endParaRPr lang="en-US" dirty="0"/>
           </a:p>
@@ -8648,12 +8648,12 @@
         </p:nvSpPr>
         <p:spPr>
           <a:xfrm>
-            <a:off x="548640" y="1783080"/>
-            <a:ext cx="3566160" cy="4206240"/>
+            <a:off x="548640" y="1691640"/>
+            <a:ext cx="2651760" cy="3611880"/>
           </a:xfrm>
           <a:prstGeom prst="roundRect">
             <a:avLst>
-              <a:gd name="adj" fmla="val 4103"/>
+              <a:gd name="adj" fmla="val 5517"/>
             </a:avLst>
           </a:prstGeom>
           <a:solidFill>
@@ -8682,8 +8682,8 @@
         </p:nvSpPr>
         <p:spPr>
           <a:xfrm>
-            <a:off x="868680" y="2057400"/>
-            <a:ext cx="2926080" cy="457200"/>
+            <a:off x="822960" y="1920240"/>
+            <a:ext cx="2103120" cy="411480"/>
           </a:xfrm>
           <a:prstGeom prst="rect">
             <a:avLst/>
@@ -8699,14 +8699,14 @@
               <a:buNone/>
             </a:pPr>
             <a:r>
-              <a:rPr lang="en-US" sz="2200" b="1" dirty="0">
+              <a:rPr lang="en-US" sz="2000" b="1" dirty="0">
                 <a:solidFill>
                   <a:schemeClr val="tx1"/>
                 </a:solidFill>
               </a:rPr>
               <a:t>Essentiel</a:t>
             </a:r>
-            <a:endParaRPr lang="en-US" sz="2200" dirty="0"/>
+            <a:endParaRPr lang="en-US" sz="2000" dirty="0"/>
           </a:p>
         </p:txBody>
       </p:sp>
@@ -8718,8 +8718,8 @@
         </p:nvSpPr>
         <p:spPr>
           <a:xfrm>
-            <a:off x="868680" y="2606040"/>
-            <a:ext cx="2926080" cy="1097280"/>
+            <a:off x="822960" y="2377440"/>
+            <a:ext cx="2103120" cy="960120"/>
           </a:xfrm>
           <a:prstGeom prst="rect">
             <a:avLst/>
@@ -8735,28 +8735,28 @@
               <a:buNone/>
             </a:pPr>
             <a:r>
-              <a:rPr lang="en-US" sz="4000" b="1" dirty="0">
+              <a:rPr lang="en-US" sz="3600" b="1" dirty="0">
                 <a:solidFill>
                   <a:schemeClr val="accent1"/>
                 </a:solidFill>
               </a:rPr>
-              <a:t>290</a:t>
-            </a:r>
-            <a:endParaRPr lang="en-US" sz="4000" dirty="0"/>
+              <a:t>390</a:t>
+            </a:r>
+            <a:endParaRPr lang="en-US" sz="3600" dirty="0"/>
           </a:p>
           <a:p>
             <a:pPr indent="0" marL="0">
               <a:buNone/>
             </a:pPr>
             <a:r>
-              <a:rPr lang="en-US" sz="1300" dirty="0">
+              <a:rPr lang="en-US" sz="1200" dirty="0">
                 <a:solidFill>
                   <a:srgbClr val="64748B"/>
                 </a:solidFill>
               </a:rPr>
               <a:t>TND HT / mois</a:t>
             </a:r>
-            <a:endParaRPr lang="en-US" sz="4000" dirty="0"/>
+            <a:endParaRPr lang="en-US" sz="3600" dirty="0"/>
           </a:p>
         </p:txBody>
       </p:sp>
@@ -8768,8 +8768,8 @@
         </p:nvSpPr>
         <p:spPr>
           <a:xfrm>
-            <a:off x="868680" y="3840480"/>
-            <a:ext cx="2971800" cy="1920240"/>
+            <a:off x="822960" y="3474720"/>
+            <a:ext cx="2194560" cy="2286000"/>
           </a:xfrm>
           <a:prstGeom prst="rect">
             <a:avLst/>
@@ -8783,74 +8783,92 @@
           <a:p>
             <a:pPr marL="342900" indent="-342900">
               <a:spcAft>
-                <a:spcPts val="600"/>
+                <a:spcPts val="500"/>
               </a:spcAft>
               <a:buSzPct val="100000"/>
               <a:buChar char="•"/>
             </a:pPr>
             <a:r>
-              <a:rPr lang="en-US" sz="1500" dirty="0">
+              <a:rPr lang="en-US" sz="1300" b="1" dirty="0">
                 <a:solidFill>
                   <a:schemeClr val="tx1"/>
                 </a:solidFill>
               </a:rPr>
-              <a:t>Jusqu’à 3 utilisateurs</a:t>
-            </a:r>
-            <a:endParaRPr lang="en-US" sz="1500" dirty="0"/>
+              <a:t>Jusqu’à 50 points</a:t>
+            </a:r>
+            <a:endParaRPr lang="en-US" sz="1300" dirty="0"/>
           </a:p>
           <a:p>
             <a:pPr marL="342900" indent="-342900">
               <a:spcAft>
-                <a:spcPts val="600"/>
+                <a:spcPts val="500"/>
               </a:spcAft>
               <a:buSzPct val="100000"/>
               <a:buChar char="•"/>
             </a:pPr>
             <a:r>
-              <a:rPr lang="en-US" sz="1500" dirty="0">
+              <a:rPr lang="en-US" sz="1300" b="1" dirty="0">
                 <a:solidFill>
                   <a:schemeClr val="tx1"/>
                 </a:solidFill>
               </a:rPr>
-              <a:t>500 points</a:t>
-            </a:r>
-            <a:endParaRPr lang="en-US" sz="1500" dirty="0"/>
+              <a:t>2 comptes bureau</a:t>
+            </a:r>
+            <a:endParaRPr lang="en-US" sz="1300" dirty="0"/>
           </a:p>
           <a:p>
             <a:pPr marL="342900" indent="-342900">
               <a:spcAft>
-                <a:spcPts val="600"/>
+                <a:spcPts val="500"/>
               </a:spcAft>
               <a:buSzPct val="100000"/>
               <a:buChar char="•"/>
             </a:pPr>
             <a:r>
-              <a:rPr lang="en-US" sz="1500" dirty="0">
+              <a:rPr lang="en-US" sz="1300" b="1" dirty="0">
                 <a:solidFill>
                   <a:schemeClr val="tx1"/>
                 </a:solidFill>
               </a:rPr>
-              <a:t>Carte, visites, démographie</a:t>
-            </a:r>
-            <a:endParaRPr lang="en-US" sz="1500" dirty="0"/>
+              <a:t>5 commerciaux</a:t>
+            </a:r>
+            <a:endParaRPr lang="en-US" sz="1300" dirty="0"/>
           </a:p>
           <a:p>
             <a:pPr marL="342900" indent="-342900">
               <a:spcAft>
-                <a:spcPts val="600"/>
+                <a:spcPts val="500"/>
               </a:spcAft>
               <a:buSzPct val="100000"/>
               <a:buChar char="•"/>
             </a:pPr>
             <a:r>
-              <a:rPr lang="en-US" sz="1500" dirty="0">
+              <a:rPr lang="en-US" sz="1300" dirty="0">
                 <a:solidFill>
                   <a:schemeClr val="tx1"/>
                 </a:solidFill>
               </a:rPr>
+              <a:t>Carte, visites, démographie</a:t>
+            </a:r>
+            <a:endParaRPr lang="en-US" sz="1300" dirty="0"/>
+          </a:p>
+          <a:p>
+            <a:pPr marL="342900" indent="-342900">
+              <a:spcAft>
+                <a:spcPts val="500"/>
+              </a:spcAft>
+              <a:buSzPct val="100000"/>
+              <a:buChar char="•"/>
+            </a:pPr>
+            <a:r>
+              <a:rPr lang="en-US" sz="1300" dirty="0">
+                <a:solidFill>
+                  <a:schemeClr val="tx1"/>
+                </a:solidFill>
+              </a:rPr>
               <a:t>Import des ventes</a:t>
             </a:r>
-            <a:endParaRPr lang="en-US" sz="1500" dirty="0"/>
+            <a:endParaRPr lang="en-US" sz="1300" dirty="0"/>
           </a:p>
         </p:txBody>
       </p:sp>
@@ -8862,12 +8880,244 @@
         </p:nvSpPr>
         <p:spPr>
           <a:xfrm>
-            <a:off x="4297680" y="1783080"/>
-            <a:ext cx="3566160" cy="4206240"/>
+            <a:off x="3353105" y="1691640"/>
+            <a:ext cx="2651760" cy="3611880"/>
           </a:xfrm>
           <a:prstGeom prst="roundRect">
             <a:avLst>
-              <a:gd name="adj" fmla="val 4103"/>
+              <a:gd name="adj" fmla="val 5517"/>
+            </a:avLst>
+          </a:prstGeom>
+          <a:solidFill>
+            <a:schemeClr val="bg1"/>
+          </a:solidFill>
+          <a:ln w="9525">
+            <a:solidFill>
+              <a:srgbClr val="E7E9F0"/>
+            </a:solidFill>
+            <a:prstDash val="solid"/>
+          </a:ln>
+          <a:effectLst>
+            <a:outerShdw sx="100000" sy="100000" kx="0" ky="0" algn="bl" rotWithShape="0" blurRad="177800" dist="38100" dir="5400000">
+              <a:srgbClr val="1E1B4B">
+                <a:alpha val="16000"/>
+              </a:srgbClr>
+            </a:outerShdw>
+          </a:effectLst>
+        </p:spPr>
+      </p:sp>
+      <p:sp>
+        <p:nvSpPr>
+          <p:cNvPr id="9" name="Text 7"/>
+          <p:cNvSpPr txBox="1"/>
+          <p:nvPr/>
+        </p:nvSpPr>
+        <p:spPr>
+          <a:xfrm>
+            <a:off x="3627425" y="1920240"/>
+            <a:ext cx="2103120" cy="411480"/>
+          </a:xfrm>
+          <a:prstGeom prst="rect">
+            <a:avLst/>
+          </a:prstGeom>
+          <a:noFill/>
+          <a:ln/>
+        </p:spPr>
+        <p:txBody>
+          <a:bodyPr wrap="square" lIns="0" tIns="0" rIns="0" bIns="0" rtlCol="0" anchor="ctr"/>
+          <a:lstStyle/>
+          <a:p>
+            <a:pPr indent="0" marL="0">
+              <a:buNone/>
+            </a:pPr>
+            <a:r>
+              <a:rPr lang="en-US" sz="2000" b="1" dirty="0">
+                <a:solidFill>
+                  <a:schemeClr val="tx1"/>
+                </a:solidFill>
+              </a:rPr>
+              <a:t>Pro</a:t>
+            </a:r>
+            <a:endParaRPr lang="en-US" sz="2000" dirty="0"/>
+          </a:p>
+        </p:txBody>
+      </p:sp>
+      <p:sp>
+        <p:nvSpPr>
+          <p:cNvPr id="10" name="Prix Pro"/>
+          <p:cNvSpPr txBox="1"/>
+          <p:nvPr/>
+        </p:nvSpPr>
+        <p:spPr>
+          <a:xfrm>
+            <a:off x="3627425" y="2377440"/>
+            <a:ext cx="2103120" cy="960120"/>
+          </a:xfrm>
+          <a:prstGeom prst="rect">
+            <a:avLst/>
+          </a:prstGeom>
+          <a:noFill/>
+          <a:ln/>
+        </p:spPr>
+        <p:txBody>
+          <a:bodyPr wrap="square" lIns="0" tIns="0" rIns="0" bIns="0" rtlCol="0" anchor="t"/>
+          <a:lstStyle/>
+          <a:p>
+            <a:pPr indent="0" marL="0">
+              <a:buNone/>
+            </a:pPr>
+            <a:r>
+              <a:rPr lang="en-US" sz="3600" b="1" dirty="0">
+                <a:solidFill>
+                  <a:schemeClr val="accent1"/>
+                </a:solidFill>
+              </a:rPr>
+              <a:t>790</a:t>
+            </a:r>
+            <a:endParaRPr lang="en-US" sz="3600" dirty="0"/>
+          </a:p>
+          <a:p>
+            <a:pPr indent="0" marL="0">
+              <a:buNone/>
+            </a:pPr>
+            <a:r>
+              <a:rPr lang="en-US" sz="1200" dirty="0">
+                <a:solidFill>
+                  <a:srgbClr val="64748B"/>
+                </a:solidFill>
+              </a:rPr>
+              <a:t>TND HT / mois</a:t>
+            </a:r>
+            <a:endParaRPr lang="en-US" sz="3600" dirty="0"/>
+          </a:p>
+        </p:txBody>
+      </p:sp>
+      <p:sp>
+        <p:nvSpPr>
+          <p:cNvPr id="11" name="Inclus Pro"/>
+          <p:cNvSpPr txBox="1"/>
+          <p:nvPr/>
+        </p:nvSpPr>
+        <p:spPr>
+          <a:xfrm>
+            <a:off x="3627425" y="3474720"/>
+            <a:ext cx="2194560" cy="2286000"/>
+          </a:xfrm>
+          <a:prstGeom prst="rect">
+            <a:avLst/>
+          </a:prstGeom>
+          <a:noFill/>
+          <a:ln/>
+        </p:spPr>
+        <p:txBody>
+          <a:bodyPr wrap="square" lIns="0" tIns="0" rIns="0" bIns="0" rtlCol="0" anchor="t"/>
+          <a:lstStyle/>
+          <a:p>
+            <a:pPr marL="342900" indent="-342900">
+              <a:spcAft>
+                <a:spcPts val="500"/>
+              </a:spcAft>
+              <a:buSzPct val="100000"/>
+              <a:buChar char="•"/>
+            </a:pPr>
+            <a:r>
+              <a:rPr lang="en-US" sz="1300" b="1" dirty="0">
+                <a:solidFill>
+                  <a:schemeClr val="tx1"/>
+                </a:solidFill>
+              </a:rPr>
+              <a:t>Jusqu’à 150 points</a:t>
+            </a:r>
+            <a:endParaRPr lang="en-US" sz="1300" dirty="0"/>
+          </a:p>
+          <a:p>
+            <a:pPr marL="342900" indent="-342900">
+              <a:spcAft>
+                <a:spcPts val="500"/>
+              </a:spcAft>
+              <a:buSzPct val="100000"/>
+              <a:buChar char="•"/>
+            </a:pPr>
+            <a:r>
+              <a:rPr lang="en-US" sz="1300" b="1" dirty="0">
+                <a:solidFill>
+                  <a:schemeClr val="tx1"/>
+                </a:solidFill>
+              </a:rPr>
+              <a:t>5 comptes bureau</a:t>
+            </a:r>
+            <a:endParaRPr lang="en-US" sz="1300" dirty="0"/>
+          </a:p>
+          <a:p>
+            <a:pPr marL="342900" indent="-342900">
+              <a:spcAft>
+                <a:spcPts val="500"/>
+              </a:spcAft>
+              <a:buSzPct val="100000"/>
+              <a:buChar char="•"/>
+            </a:pPr>
+            <a:r>
+              <a:rPr lang="en-US" sz="1300" b="1" dirty="0">
+                <a:solidFill>
+                  <a:schemeClr val="tx1"/>
+                </a:solidFill>
+              </a:rPr>
+              <a:t>15 commerciaux</a:t>
+            </a:r>
+            <a:endParaRPr lang="en-US" sz="1300" dirty="0"/>
+          </a:p>
+          <a:p>
+            <a:pPr marL="342900" indent="-342900">
+              <a:spcAft>
+                <a:spcPts val="500"/>
+              </a:spcAft>
+              <a:buSzPct val="100000"/>
+              <a:buChar char="•"/>
+            </a:pPr>
+            <a:r>
+              <a:rPr lang="en-US" sz="1300" dirty="0">
+                <a:solidFill>
+                  <a:schemeClr val="tx1"/>
+                </a:solidFill>
+              </a:rPr>
+              <a:t>Tout Essentiel</a:t>
+            </a:r>
+            <a:endParaRPr lang="en-US" sz="1300" dirty="0"/>
+          </a:p>
+          <a:p>
+            <a:pPr marL="342900" indent="-342900">
+              <a:spcAft>
+                <a:spcPts val="500"/>
+              </a:spcAft>
+              <a:buSzPct val="100000"/>
+              <a:buChar char="•"/>
+            </a:pPr>
+            <a:r>
+              <a:rPr lang="en-US" sz="1300" dirty="0">
+                <a:solidFill>
+                  <a:schemeClr val="tx1"/>
+                </a:solidFill>
+              </a:rPr>
+              <a:t>Simulateur, comparateur et rapport PDF</a:t>
+            </a:r>
+            <a:endParaRPr lang="en-US" sz="1300" dirty="0"/>
+          </a:p>
+        </p:txBody>
+      </p:sp>
+      <p:sp>
+        <p:nvSpPr>
+          <p:cNvPr id="12" name="Formule Business"/>
+          <p:cNvSpPr/>
+          <p:nvPr/>
+        </p:nvSpPr>
+        <p:spPr>
+          <a:xfrm>
+            <a:off x="6157570" y="1691640"/>
+            <a:ext cx="2651760" cy="3611880"/>
+          </a:xfrm>
+          <a:prstGeom prst="roundRect">
+            <a:avLst>
+              <a:gd name="adj" fmla="val 5517"/>
             </a:avLst>
           </a:prstGeom>
           <a:solidFill>
@@ -8890,14 +9140,14 @@
       </p:sp>
       <p:sp>
         <p:nvSpPr>
-          <p:cNvPr id="9" name="Text 7"/>
+          <p:cNvPr id="13" name="Text 11"/>
           <p:cNvSpPr txBox="1"/>
           <p:nvPr/>
         </p:nvSpPr>
         <p:spPr>
           <a:xfrm>
-            <a:off x="4617720" y="2057400"/>
-            <a:ext cx="2926080" cy="457200"/>
+            <a:off x="6431890" y="1920240"/>
+            <a:ext cx="2103120" cy="411480"/>
           </a:xfrm>
           <a:prstGeom prst="rect">
             <a:avLst/>
@@ -8913,27 +9163,27 @@
               <a:buNone/>
             </a:pPr>
             <a:r>
-              <a:rPr lang="en-US" sz="2200" b="1" dirty="0">
+              <a:rPr lang="en-US" sz="2000" b="1" dirty="0">
                 <a:solidFill>
                   <a:schemeClr val="bg1"/>
                 </a:solidFill>
               </a:rPr>
-              <a:t>Pro</a:t>
-            </a:r>
-            <a:endParaRPr lang="en-US" sz="2200" dirty="0"/>
-          </a:p>
-        </p:txBody>
-      </p:sp>
-      <p:sp>
-        <p:nvSpPr>
-          <p:cNvPr id="10" name="Prix Pro"/>
+              <a:t>Business</a:t>
+            </a:r>
+            <a:endParaRPr lang="en-US" sz="2000" dirty="0"/>
+          </a:p>
+        </p:txBody>
+      </p:sp>
+      <p:sp>
+        <p:nvSpPr>
+          <p:cNvPr id="14" name="Prix Business"/>
           <p:cNvSpPr txBox="1"/>
           <p:nvPr/>
         </p:nvSpPr>
         <p:spPr>
           <a:xfrm>
-            <a:off x="4617720" y="2606040"/>
-            <a:ext cx="2926080" cy="1097280"/>
+            <a:off x="6431890" y="2377440"/>
+            <a:ext cx="2103120" cy="960120"/>
           </a:xfrm>
           <a:prstGeom prst="rect">
             <a:avLst/>
@@ -8949,41 +9199,41 @@
               <a:buNone/>
             </a:pPr>
             <a:r>
-              <a:rPr lang="en-US" sz="4000" b="1" dirty="0">
+              <a:rPr lang="en-US" sz="3600" b="1" dirty="0">
                 <a:solidFill>
                   <a:schemeClr val="bg1"/>
                 </a:solidFill>
               </a:rPr>
-              <a:t>690</a:t>
-            </a:r>
-            <a:endParaRPr lang="en-US" sz="4000" dirty="0"/>
+              <a:t>1 290</a:t>
+            </a:r>
+            <a:endParaRPr lang="en-US" sz="3600" dirty="0"/>
           </a:p>
           <a:p>
             <a:pPr indent="0" marL="0">
               <a:buNone/>
             </a:pPr>
             <a:r>
-              <a:rPr lang="en-US" sz="1300" dirty="0">
+              <a:rPr lang="en-US" sz="1200" dirty="0">
                 <a:solidFill>
                   <a:srgbClr val="C7D2FE"/>
                 </a:solidFill>
               </a:rPr>
               <a:t>TND HT / mois</a:t>
             </a:r>
-            <a:endParaRPr lang="en-US" sz="4000" dirty="0"/>
-          </a:p>
-        </p:txBody>
-      </p:sp>
-      <p:sp>
-        <p:nvSpPr>
-          <p:cNvPr id="11" name="Inclus Pro"/>
+            <a:endParaRPr lang="en-US" sz="3600" dirty="0"/>
+          </a:p>
+        </p:txBody>
+      </p:sp>
+      <p:sp>
+        <p:nvSpPr>
+          <p:cNvPr id="15" name="Inclus Business"/>
           <p:cNvSpPr txBox="1"/>
           <p:nvPr/>
         </p:nvSpPr>
         <p:spPr>
           <a:xfrm>
-            <a:off x="4617720" y="3840480"/>
-            <a:ext cx="2971800" cy="1920240"/>
+            <a:off x="6431890" y="3474720"/>
+            <a:ext cx="2194560" cy="2286000"/>
           </a:xfrm>
           <a:prstGeom prst="rect">
             <a:avLst/>
@@ -8997,91 +9247,109 @@
           <a:p>
             <a:pPr marL="342900" indent="-342900">
               <a:spcAft>
-                <a:spcPts val="600"/>
+                <a:spcPts val="500"/>
               </a:spcAft>
               <a:buSzPct val="100000"/>
               <a:buChar char="•"/>
             </a:pPr>
             <a:r>
-              <a:rPr lang="en-US" sz="1500" dirty="0">
+              <a:rPr lang="en-US" sz="1300" b="1" dirty="0">
                 <a:solidFill>
                   <a:schemeClr val="bg1"/>
                 </a:solidFill>
               </a:rPr>
-              <a:t>Jusqu’à 10 utilisateurs</a:t>
-            </a:r>
-            <a:endParaRPr lang="en-US" sz="1500" dirty="0"/>
+              <a:t>Jusqu’à 400 points</a:t>
+            </a:r>
+            <a:endParaRPr lang="en-US" sz="1300" dirty="0"/>
           </a:p>
           <a:p>
             <a:pPr marL="342900" indent="-342900">
               <a:spcAft>
-                <a:spcPts val="600"/>
+                <a:spcPts val="500"/>
               </a:spcAft>
               <a:buSzPct val="100000"/>
               <a:buChar char="•"/>
             </a:pPr>
             <a:r>
-              <a:rPr lang="en-US" sz="1500" dirty="0">
+              <a:rPr lang="en-US" sz="1300" b="1" dirty="0">
                 <a:solidFill>
                   <a:schemeClr val="bg1"/>
                 </a:solidFill>
               </a:rPr>
-              <a:t>Points illimités</a:t>
-            </a:r>
-            <a:endParaRPr lang="en-US" sz="1500" dirty="0"/>
+              <a:t>10 comptes bureau</a:t>
+            </a:r>
+            <a:endParaRPr lang="en-US" sz="1300" dirty="0"/>
           </a:p>
           <a:p>
             <a:pPr marL="342900" indent="-342900">
               <a:spcAft>
-                <a:spcPts val="600"/>
+                <a:spcPts val="500"/>
               </a:spcAft>
               <a:buSzPct val="100000"/>
               <a:buChar char="•"/>
             </a:pPr>
             <a:r>
-              <a:rPr lang="en-US" sz="1500" dirty="0">
+              <a:rPr lang="en-US" sz="1300" b="1" dirty="0">
                 <a:solidFill>
                   <a:schemeClr val="bg1"/>
                 </a:solidFill>
               </a:rPr>
-              <a:t>Simulateur et comparateur</a:t>
-            </a:r>
-            <a:endParaRPr lang="en-US" sz="1500" dirty="0"/>
+              <a:t>30 commerciaux</a:t>
+            </a:r>
+            <a:endParaRPr lang="en-US" sz="1300" dirty="0"/>
           </a:p>
           <a:p>
             <a:pPr marL="342900" indent="-342900">
               <a:spcAft>
-                <a:spcPts val="600"/>
+                <a:spcPts val="500"/>
               </a:spcAft>
               <a:buSzPct val="100000"/>
               <a:buChar char="•"/>
             </a:pPr>
             <a:r>
-              <a:rPr lang="en-US" sz="1500" dirty="0">
+              <a:rPr lang="en-US" sz="1300" dirty="0">
                 <a:solidFill>
                   <a:schemeClr val="bg1"/>
                 </a:solidFill>
               </a:rPr>
-              <a:t>Saisonnalité et couverture</a:t>
-            </a:r>
-            <a:endParaRPr lang="en-US" sz="1500" dirty="0"/>
-          </a:p>
-        </p:txBody>
-      </p:sp>
-      <p:sp>
-        <p:nvSpPr>
-          <p:cNvPr id="12" name="Formule Entreprise"/>
+              <a:t>Tout Pro</a:t>
+            </a:r>
+            <a:endParaRPr lang="en-US" sz="1300" dirty="0"/>
+          </a:p>
+          <a:p>
+            <a:pPr marL="342900" indent="-342900">
+              <a:spcAft>
+                <a:spcPts val="500"/>
+              </a:spcAft>
+              <a:buSzPct val="100000"/>
+              <a:buChar char="•"/>
+            </a:pPr>
+            <a:r>
+              <a:rPr lang="en-US" sz="1300" dirty="0">
+                <a:solidFill>
+                  <a:schemeClr val="bg1"/>
+                </a:solidFill>
+              </a:rPr>
+              <a:t>Saisonnalité, couverture, zone de chalandise</a:t>
+            </a:r>
+            <a:endParaRPr lang="en-US" sz="1300" dirty="0"/>
+          </a:p>
+        </p:txBody>
+      </p:sp>
+      <p:sp>
+        <p:nvSpPr>
+          <p:cNvPr id="16" name="Formule Entreprise"/>
           <p:cNvSpPr/>
           <p:nvPr/>
         </p:nvSpPr>
         <p:spPr>
           <a:xfrm>
-            <a:off x="8046720" y="1783080"/>
-            <a:ext cx="3566160" cy="4206240"/>
+            <a:off x="8962034" y="1691640"/>
+            <a:ext cx="2651760" cy="3611880"/>
           </a:xfrm>
           <a:prstGeom prst="roundRect">
             <a:avLst>
-              <a:gd name="adj" fmla="val 4103"/>
+              <a:gd name="adj" fmla="val 5517"/>
             </a:avLst>
           </a:prstGeom>
           <a:solidFill>
@@ -9104,14 +9372,14 @@
       </p:sp>
       <p:sp>
         <p:nvSpPr>
-          <p:cNvPr id="13" name="Text 11"/>
+          <p:cNvPr id="17" name="Text 15"/>
           <p:cNvSpPr txBox="1"/>
           <p:nvPr/>
         </p:nvSpPr>
         <p:spPr>
           <a:xfrm>
-            <a:off x="8366760" y="2057400"/>
-            <a:ext cx="2926080" cy="457200"/>
+            <a:off x="9236354" y="1920240"/>
+            <a:ext cx="2103120" cy="411480"/>
           </a:xfrm>
           <a:prstGeom prst="rect">
             <a:avLst/>
@@ -9127,27 +9395,27 @@
               <a:buNone/>
             </a:pPr>
             <a:r>
-              <a:rPr lang="en-US" sz="2200" b="1" dirty="0">
+              <a:rPr lang="en-US" sz="2000" b="1" dirty="0">
                 <a:solidFill>
                   <a:schemeClr val="tx1"/>
                 </a:solidFill>
               </a:rPr>
               <a:t>Entreprise</a:t>
             </a:r>
-            <a:endParaRPr lang="en-US" sz="2200" dirty="0"/>
-          </a:p>
-        </p:txBody>
-      </p:sp>
-      <p:sp>
-        <p:nvSpPr>
-          <p:cNvPr id="14" name="Prix Entreprise"/>
+            <a:endParaRPr lang="en-US" sz="2000" dirty="0"/>
+          </a:p>
+        </p:txBody>
+      </p:sp>
+      <p:sp>
+        <p:nvSpPr>
+          <p:cNvPr id="18" name="Prix Entreprise"/>
           <p:cNvSpPr txBox="1"/>
           <p:nvPr/>
         </p:nvSpPr>
         <p:spPr>
           <a:xfrm>
-            <a:off x="8366760" y="2606040"/>
-            <a:ext cx="2926080" cy="1097280"/>
+            <a:off x="9236354" y="2377440"/>
+            <a:ext cx="2103120" cy="960120"/>
           </a:xfrm>
           <a:prstGeom prst="rect">
             <a:avLst/>
@@ -9163,41 +9431,41 @@
               <a:buNone/>
             </a:pPr>
             <a:r>
-              <a:rPr lang="en-US" sz="3000" b="1" dirty="0">
+              <a:rPr lang="en-US" sz="3600" b="1" dirty="0">
                 <a:solidFill>
                   <a:schemeClr val="accent1"/>
                 </a:solidFill>
               </a:rPr>
-              <a:t>Sur devis</a:t>
-            </a:r>
-            <a:endParaRPr lang="en-US" sz="3000" dirty="0"/>
+              <a:t>1 900</a:t>
+            </a:r>
+            <a:endParaRPr lang="en-US" sz="3600" dirty="0"/>
           </a:p>
           <a:p>
             <a:pPr indent="0" marL="0">
               <a:buNone/>
             </a:pPr>
             <a:r>
-              <a:rPr lang="en-US" sz="1300" dirty="0">
+              <a:rPr lang="en-US" sz="1200" dirty="0">
                 <a:solidFill>
                   <a:srgbClr val="64748B"/>
                 </a:solidFill>
               </a:rPr>
-              <a:t> </a:t>
-            </a:r>
-            <a:endParaRPr lang="en-US" sz="3000" dirty="0"/>
-          </a:p>
-        </p:txBody>
-      </p:sp>
-      <p:sp>
-        <p:nvSpPr>
-          <p:cNvPr id="15" name="Inclus Entreprise"/>
+              <a:t>TND HT / mois</a:t>
+            </a:r>
+            <a:endParaRPr lang="en-US" sz="3600" dirty="0"/>
+          </a:p>
+        </p:txBody>
+      </p:sp>
+      <p:sp>
+        <p:nvSpPr>
+          <p:cNvPr id="19" name="Inclus Entreprise"/>
           <p:cNvSpPr txBox="1"/>
           <p:nvPr/>
         </p:nvSpPr>
         <p:spPr>
           <a:xfrm>
-            <a:off x="8366760" y="3840480"/>
-            <a:ext cx="2971800" cy="1920240"/>
+            <a:off x="9236354" y="3474720"/>
+            <a:ext cx="2194560" cy="2286000"/>
           </a:xfrm>
           <a:prstGeom prst="rect">
             <a:avLst/>
@@ -9211,86 +9479,104 @@
           <a:p>
             <a:pPr marL="342900" indent="-342900">
               <a:spcAft>
-                <a:spcPts val="600"/>
+                <a:spcPts val="500"/>
               </a:spcAft>
               <a:buSzPct val="100000"/>
               <a:buChar char="•"/>
             </a:pPr>
             <a:r>
-              <a:rPr lang="en-US" sz="1500" dirty="0">
+              <a:rPr lang="en-US" sz="1300" b="1" dirty="0">
                 <a:solidFill>
                   <a:schemeClr val="tx1"/>
                 </a:solidFill>
               </a:rPr>
-              <a:t>Utilisateurs illimités</a:t>
-            </a:r>
-            <a:endParaRPr lang="en-US" sz="1500" dirty="0"/>
+              <a:t>Points illimités</a:t>
+            </a:r>
+            <a:endParaRPr lang="en-US" sz="1300" dirty="0"/>
           </a:p>
           <a:p>
             <a:pPr marL="342900" indent="-342900">
               <a:spcAft>
-                <a:spcPts val="600"/>
+                <a:spcPts val="500"/>
               </a:spcAft>
               <a:buSzPct val="100000"/>
               <a:buChar char="•"/>
             </a:pPr>
             <a:r>
-              <a:rPr lang="en-US" sz="1500" dirty="0">
+              <a:rPr lang="en-US" sz="1300" b="1" dirty="0">
                 <a:solidFill>
                   <a:schemeClr val="tx1"/>
                 </a:solidFill>
               </a:rPr>
-              <a:t>Accompagnement dédié</a:t>
-            </a:r>
-            <a:endParaRPr lang="en-US" sz="1500" dirty="0"/>
+              <a:t>Comptes bureau illimités</a:t>
+            </a:r>
+            <a:endParaRPr lang="en-US" sz="1300" dirty="0"/>
           </a:p>
           <a:p>
             <a:pPr marL="342900" indent="-342900">
               <a:spcAft>
-                <a:spcPts val="600"/>
+                <a:spcPts val="500"/>
               </a:spcAft>
               <a:buSzPct val="100000"/>
               <a:buChar char="•"/>
             </a:pPr>
             <a:r>
-              <a:rPr lang="en-US" sz="1500" dirty="0">
+              <a:rPr lang="en-US" sz="1300" b="1" dirty="0">
                 <a:solidFill>
                   <a:schemeClr val="tx1"/>
                 </a:solidFill>
               </a:rPr>
-              <a:t>Import de votre ERP</a:t>
-            </a:r>
-            <a:endParaRPr lang="en-US" sz="1500" dirty="0"/>
+              <a:t>60 commerciaux</a:t>
+            </a:r>
+            <a:endParaRPr lang="en-US" sz="1300" dirty="0"/>
           </a:p>
           <a:p>
             <a:pPr marL="342900" indent="-342900">
               <a:spcAft>
-                <a:spcPts val="600"/>
+                <a:spcPts val="500"/>
               </a:spcAft>
               <a:buSzPct val="100000"/>
               <a:buChar char="•"/>
             </a:pPr>
             <a:r>
-              <a:rPr lang="en-US" sz="1500" dirty="0">
+              <a:rPr lang="en-US" sz="1300" dirty="0">
                 <a:solidFill>
                   <a:schemeClr val="tx1"/>
                 </a:solidFill>
               </a:rPr>
-              <a:t>Formation des équipes</a:t>
-            </a:r>
-            <a:endParaRPr lang="en-US" sz="1500" dirty="0"/>
-          </a:p>
-        </p:txBody>
-      </p:sp>
-      <p:sp>
-        <p:nvSpPr>
-          <p:cNvPr id="16" name="Text 14"/>
+              <a:t>Tout Business</a:t>
+            </a:r>
+            <a:endParaRPr lang="en-US" sz="1300" dirty="0"/>
+          </a:p>
+          <a:p>
+            <a:pPr marL="342900" indent="-342900">
+              <a:spcAft>
+                <a:spcPts val="500"/>
+              </a:spcAft>
+              <a:buSzPct val="100000"/>
+              <a:buChar char="•"/>
+            </a:pPr>
+            <a:r>
+              <a:rPr lang="en-US" sz="1300" dirty="0">
+                <a:solidFill>
+                  <a:schemeClr val="tx1"/>
+                </a:solidFill>
+              </a:rPr>
+              <a:t>Import ERP, accompagnement, formation</a:t>
+            </a:r>
+            <a:endParaRPr lang="en-US" sz="1300" dirty="0"/>
+          </a:p>
+        </p:txBody>
+      </p:sp>
+      <p:sp>
+        <p:nvSpPr>
+          <p:cNvPr id="20" name="Text 18"/>
           <p:cNvSpPr txBox="1"/>
           <p:nvPr/>
         </p:nvSpPr>
         <p:spPr>
           <a:xfrm>
-            <a:off x="548640" y="6080760"/>
+            <a:off x="548640" y="5577840"/>
             <a:ext cx="11064240" cy="320040"/>
           </a:xfrm>
           <a:prstGeom prst="rect">
@@ -9312,7 +9598,7 @@
                   <a:srgbClr val="64748B"/>
                 </a:solidFill>
               </a:rPr>
-              <a:t>30 jours d’essai gratuit pour toute nouvelle société.</a:t>
+              <a:t>Comptes bureau : administrateur et managers. Commercial supplémentaire : 15 TND HT / mois. 30 jours d’essai gratuit.</a:t>
             </a:r>
             <a:endParaRPr lang="en-US" sz="1400" dirty="0"/>
           </a:p>

</xml_diff>